<commit_message>
Correct presentation to two-view readiness (strict ~0% + graded 42/12/46); regenerate docx/pptx/chart; fix build scripts
</commit_message>
<xml_diff>
--- a/presentation/slide_deck.pptx
+++ b/presentation/slide_deck.pptx
@@ -728,7 +728,7 @@
           <a:lstStyle/>
           <a:p>
             <a:r>
-              <a:t>This chart is the single clearest proof that the verdict engine is a real, working, configurable system and not a fixed script - same 750 invoices, same underlying signals, three different answers depending on the policy toggled. Strict landing at exactly 0% is not a bug: this corpus is unsigned digital templates, Diana's detector correctly finds 0/750 stamps or signatures on it, and a policy that requires a visual mark will fail-closed on all of them. That is the fail-closed design working as intended, and we say so directly rather than hiding a 0% number.</a:t>
+              <a:t>The verdict engine is a real, configurable system - same 750 invoices, different honest outcomes. The strict Default is ~0% because the corpus carries no PO/contract references (an earlier 63.3% there was a loose-matching artifact, since corrected); Strict is 0% because there are no stamps/signatures - fail-closed working as intended. Because the strict gate can't differentiate this corpus, we add a standardized graded completeness score (Ready 42%, Needs review 12%, Not ready 46%) that yields a meaningful, auditable spread.</a:t>
             </a:r>
           </a:p>
         </p:txBody>
@@ -868,7 +868,7 @@
           <a:lstStyle/>
           <a:p>
             <a:r>
-              <a:t>These are the final numbers - every one of them is traceable to a specific metrics JSON or the final_pipeline_report.md. Be ready to state the full readiness spread (Lenient 100% / Default 63.3% / Strict 0%) if asked, and to explain the Strict=0% result the same honest way it's framed on the readiness-spread slide.</a:t>
+              <a:t>These are the final numbers - traceable to each metrics JSON or the final_pipeline_report.md. State the strict readiness spread (Lenient 100% / Default ~0% / Strict 0%) and the graded completeness score (Ready 42%) if asked; the earlier Default 63.3% was a loose-matching artifact, since corrected, and Strict=0% is the fail-closed design on an unsigned corpus.</a:t>
             </a:r>
           </a:p>
         </p:txBody>
@@ -5358,7 +5358,7 @@
                   <a:srgbClr val="1A3A5C"/>
                 </a:solidFill>
               </a:rPr>
-              <a:t>The Readiness Spread — Same 750 Invoices, Three Policies</a:t>
+              <a:t>The Readiness Spread — Same 750 Invoices, Two Views</a:t>
             </a:r>
           </a:p>
         </p:txBody>
@@ -5379,8 +5379,8 @@
         </p:blipFill>
         <p:spPr>
           <a:xfrm>
-            <a:off x="2755450" y="1051560"/>
-            <a:ext cx="6650620" cy="4206240"/>
+            <a:off x="2194560" y="1573460"/>
+            <a:ext cx="7772400" cy="3162439"/>
           </a:xfrm>
           <a:prstGeom prst="rect">
             <a:avLst/>
@@ -5420,7 +5420,7 @@
                   <a:srgbClr val="202020"/>
                 </a:solidFill>
               </a:rPr>
-              <a:t>• Lenient (no visual-mark requirement): 750 / 750 (100%) ready</a:t>
+              <a:t>• Strict policies (fail-closed): Lenient 750/750 (100%), Default ~0/750 (~0%), Strict 0/750 (0%)</a:t>
             </a:r>
           </a:p>
           <a:p>
@@ -5435,7 +5435,7 @@
                   <a:srgbClr val="202020"/>
                 </a:solidFill>
               </a:rPr>
-              <a:t>• Default (reference number + date, no visual-mark requirement): 475 / 750 (63.3%) ready</a:t>
+              <a:t>• Default ~0% = corpus carries no PO/contract references (earlier 63.3% was a matching artifact, corrected)</a:t>
             </a:r>
           </a:p>
           <a:p>
@@ -5450,7 +5450,7 @@
                   <a:srgbClr val="202020"/>
                 </a:solidFill>
               </a:rPr>
-              <a:t>• Strict (requires stamp AND signature): 0 / 750 (0%) ready</a:t>
+              <a:t>• Graded completeness: Ready 315/750 (42.0%), Needs review 93 (12.4%), Not ready 342 (45.6%), mean 76.3</a:t>
             </a:r>
           </a:p>
         </p:txBody>
@@ -5970,7 +5970,7 @@
                             <a:srgbClr val="202020"/>
                           </a:solidFill>
                         </a:rPr>
-                        <a:t>N of 750 Ready under Default policy</a:t>
+                        <a:t>Readiness: strict / graded</a:t>
                       </a:r>
                     </a:p>
                   </a:txBody>
@@ -5992,7 +5992,7 @@
                             <a:srgbClr val="202020"/>
                           </a:solidFill>
                         </a:rPr>
-                        <a:t>475 / 750 (63.3%)</a:t>
+                        <a:t>Default ~0%, Lenient 100%, Strict 0% / Ready 42.0% (315/750)</a:t>
                       </a:r>
                     </a:p>
                   </a:txBody>

</xml_diff>